<commit_message>
added pdf for agnda
</commit_message>
<xml_diff>
--- a/STP/presentations/Sesssion_1/Introduction and agenda.pptx
+++ b/STP/presentations/Sesssion_1/Introduction and agenda.pptx
@@ -733,7 +733,7 @@
           <a:p>
             <a:fld id="{F8A8B291-23C9-4CE5-96D0-E0118EB6230C}" type="datetimeFigureOut">
               <a:rPr lang="en-GB" smtClean="0"/>
-              <a:t>29/11/2025</a:t>
+              <a:t>30/11/2025</a:t>
             </a:fld>
             <a:endParaRPr lang="en-GB"/>
           </a:p>
@@ -933,7 +933,7 @@
           <a:p>
             <a:fld id="{F8A8B291-23C9-4CE5-96D0-E0118EB6230C}" type="datetimeFigureOut">
               <a:rPr lang="en-GB" smtClean="0"/>
-              <a:t>29/11/2025</a:t>
+              <a:t>30/11/2025</a:t>
             </a:fld>
             <a:endParaRPr lang="en-GB"/>
           </a:p>
@@ -1143,7 +1143,7 @@
           <a:p>
             <a:fld id="{F8A8B291-23C9-4CE5-96D0-E0118EB6230C}" type="datetimeFigureOut">
               <a:rPr lang="en-GB" smtClean="0"/>
-              <a:t>29/11/2025</a:t>
+              <a:t>30/11/2025</a:t>
             </a:fld>
             <a:endParaRPr lang="en-GB"/>
           </a:p>
@@ -1343,7 +1343,7 @@
           <a:p>
             <a:fld id="{F8A8B291-23C9-4CE5-96D0-E0118EB6230C}" type="datetimeFigureOut">
               <a:rPr lang="en-GB" smtClean="0"/>
-              <a:t>29/11/2025</a:t>
+              <a:t>30/11/2025</a:t>
             </a:fld>
             <a:endParaRPr lang="en-GB"/>
           </a:p>
@@ -1619,7 +1619,7 @@
           <a:p>
             <a:fld id="{F8A8B291-23C9-4CE5-96D0-E0118EB6230C}" type="datetimeFigureOut">
               <a:rPr lang="en-GB" smtClean="0"/>
-              <a:t>29/11/2025</a:t>
+              <a:t>30/11/2025</a:t>
             </a:fld>
             <a:endParaRPr lang="en-GB"/>
           </a:p>
@@ -1887,7 +1887,7 @@
           <a:p>
             <a:fld id="{F8A8B291-23C9-4CE5-96D0-E0118EB6230C}" type="datetimeFigureOut">
               <a:rPr lang="en-GB" smtClean="0"/>
-              <a:t>29/11/2025</a:t>
+              <a:t>30/11/2025</a:t>
             </a:fld>
             <a:endParaRPr lang="en-GB"/>
           </a:p>
@@ -2302,7 +2302,7 @@
           <a:p>
             <a:fld id="{F8A8B291-23C9-4CE5-96D0-E0118EB6230C}" type="datetimeFigureOut">
               <a:rPr lang="en-GB" smtClean="0"/>
-              <a:t>29/11/2025</a:t>
+              <a:t>30/11/2025</a:t>
             </a:fld>
             <a:endParaRPr lang="en-GB"/>
           </a:p>
@@ -2444,7 +2444,7 @@
           <a:p>
             <a:fld id="{F8A8B291-23C9-4CE5-96D0-E0118EB6230C}" type="datetimeFigureOut">
               <a:rPr lang="en-GB" smtClean="0"/>
-              <a:t>29/11/2025</a:t>
+              <a:t>30/11/2025</a:t>
             </a:fld>
             <a:endParaRPr lang="en-GB"/>
           </a:p>
@@ -2557,7 +2557,7 @@
           <a:p>
             <a:fld id="{F8A8B291-23C9-4CE5-96D0-E0118EB6230C}" type="datetimeFigureOut">
               <a:rPr lang="en-GB" smtClean="0"/>
-              <a:t>29/11/2025</a:t>
+              <a:t>30/11/2025</a:t>
             </a:fld>
             <a:endParaRPr lang="en-GB"/>
           </a:p>
@@ -2870,7 +2870,7 @@
           <a:p>
             <a:fld id="{F8A8B291-23C9-4CE5-96D0-E0118EB6230C}" type="datetimeFigureOut">
               <a:rPr lang="en-GB" smtClean="0"/>
-              <a:t>29/11/2025</a:t>
+              <a:t>30/11/2025</a:t>
             </a:fld>
             <a:endParaRPr lang="en-GB"/>
           </a:p>
@@ -3159,7 +3159,7 @@
           <a:p>
             <a:fld id="{F8A8B291-23C9-4CE5-96D0-E0118EB6230C}" type="datetimeFigureOut">
               <a:rPr lang="en-GB" smtClean="0"/>
-              <a:t>29/11/2025</a:t>
+              <a:t>30/11/2025</a:t>
             </a:fld>
             <a:endParaRPr lang="en-GB"/>
           </a:p>
@@ -3402,7 +3402,7 @@
           <a:p>
             <a:fld id="{F8A8B291-23C9-4CE5-96D0-E0118EB6230C}" type="datetimeFigureOut">
               <a:rPr lang="en-GB" smtClean="0"/>
-              <a:t>29/11/2025</a:t>
+              <a:t>30/11/2025</a:t>
             </a:fld>
             <a:endParaRPr lang="en-GB"/>
           </a:p>
@@ -6046,7 +6046,7 @@
         <p:spPr>
           <a:xfrm>
             <a:off x="423876" y="1485900"/>
-            <a:ext cx="11188700" cy="4488793"/>
+            <a:ext cx="11188700" cy="4858125"/>
           </a:xfrm>
           <a:prstGeom prst="rect">
             <a:avLst/>
@@ -6120,7 +6120,55 @@
             </a:r>
             <a:r>
               <a:rPr lang="en-GB" sz="1600" dirty="0"/>
-              <a:t> de Oxford e </a:t>
+              <a:t> de Oxford, </a:t>
+            </a:r>
+            <a:r>
+              <a:rPr lang="en-GB" sz="1600" dirty="0" err="1"/>
+              <a:t>onde</a:t>
+            </a:r>
+            <a:r>
+              <a:rPr lang="en-GB" sz="1600" dirty="0"/>
+              <a:t> se </a:t>
+            </a:r>
+            <a:r>
+              <a:rPr lang="en-GB" sz="1600" dirty="0" err="1"/>
+              <a:t>especializou</a:t>
+            </a:r>
+            <a:r>
+              <a:rPr lang="en-GB" sz="1600" dirty="0"/>
+              <a:t> </a:t>
+            </a:r>
+            <a:r>
+              <a:rPr lang="en-GB" sz="1600" dirty="0" err="1"/>
+              <a:t>em</a:t>
+            </a:r>
+            <a:r>
+              <a:rPr lang="en-GB" sz="1600" dirty="0"/>
+              <a:t> </a:t>
+            </a:r>
+            <a:r>
+              <a:rPr lang="en-GB" sz="1600" dirty="0" err="1"/>
+              <a:t>modelagem</a:t>
+            </a:r>
+            <a:r>
+              <a:rPr lang="en-GB" sz="1600" dirty="0"/>
+              <a:t> de </a:t>
+            </a:r>
+            <a:r>
+              <a:rPr lang="en-GB" sz="1600" dirty="0" err="1"/>
+              <a:t>ecossistemas</a:t>
+            </a:r>
+            <a:r>
+              <a:rPr lang="en-GB" sz="1600" dirty="0"/>
+              <a:t>, e </a:t>
+            </a:r>
+            <a:r>
+              <a:rPr lang="en-GB" sz="1600" dirty="0" err="1"/>
+              <a:t>é</a:t>
+            </a:r>
+            <a:r>
+              <a:rPr lang="en-GB" sz="1600" dirty="0"/>
+              <a:t> </a:t>
             </a:r>
             <a:r>
               <a:rPr lang="en-GB" sz="1600" dirty="0" err="1"/>
@@ -6588,6 +6636,70 @@
             <a:r>
               <a:rPr lang="en-GB" sz="1600" dirty="0" err="1"/>
               <a:t>Unido</a:t>
+            </a:r>
+            <a:r>
+              <a:rPr lang="en-GB" sz="1600" dirty="0"/>
+              <a:t>, </a:t>
+            </a:r>
+            <a:r>
+              <a:rPr lang="en-GB" sz="1600" dirty="0" err="1"/>
+              <a:t>onde</a:t>
+            </a:r>
+            <a:r>
+              <a:rPr lang="en-GB" sz="1600" dirty="0"/>
+              <a:t> se </a:t>
+            </a:r>
+            <a:r>
+              <a:rPr lang="en-GB" sz="1600" dirty="0" err="1"/>
+              <a:t>especializou</a:t>
+            </a:r>
+            <a:r>
+              <a:rPr lang="en-GB" sz="1600" dirty="0"/>
+              <a:t> </a:t>
+            </a:r>
+            <a:r>
+              <a:rPr lang="en-GB" sz="1600" dirty="0" err="1"/>
+              <a:t>em</a:t>
+            </a:r>
+            <a:r>
+              <a:rPr lang="en-GB" sz="1600" dirty="0"/>
+              <a:t> </a:t>
+            </a:r>
+            <a:r>
+              <a:rPr lang="en-GB" sz="1600" dirty="0" err="1"/>
+              <a:t>modelagem</a:t>
+            </a:r>
+            <a:r>
+              <a:rPr lang="en-GB" sz="1600" dirty="0"/>
+              <a:t> de </a:t>
+            </a:r>
+            <a:r>
+              <a:rPr lang="en-GB" sz="1600" dirty="0" err="1"/>
+              <a:t>estresse</a:t>
+            </a:r>
+            <a:r>
+              <a:rPr lang="en-GB" sz="1600" dirty="0"/>
+              <a:t> </a:t>
+            </a:r>
+            <a:r>
+              <a:rPr lang="en-GB" sz="1600" dirty="0" err="1"/>
+              <a:t>térmico</a:t>
+            </a:r>
+            <a:r>
+              <a:rPr lang="en-GB" sz="1600" dirty="0"/>
+              <a:t> </a:t>
+            </a:r>
+            <a:r>
+              <a:rPr lang="en-GB" sz="1600" dirty="0" err="1"/>
+              <a:t>em</a:t>
+            </a:r>
+            <a:r>
+              <a:rPr lang="en-GB" sz="1600" dirty="0"/>
+              <a:t> </a:t>
+            </a:r>
+            <a:r>
+              <a:rPr lang="en-GB" sz="1600" dirty="0" err="1"/>
+              <a:t>ecossistemas</a:t>
             </a:r>
             <a:r>
               <a:rPr lang="en-GB" sz="1600" dirty="0"/>
@@ -7815,6 +7927,26 @@
 </file>
 
 <file path=customXml/item1.xml><?xml version="1.0" encoding="utf-8"?>
+<?mso-contentType ?>
+<FormTemplates xmlns="http://schemas.microsoft.com/sharepoint/v3/contenttype/forms">
+  <Display>DocumentLibraryForm</Display>
+  <Edit>DocumentLibraryForm</Edit>
+  <New>DocumentLibraryForm</New>
+</FormTemplates>
+</file>
+
+<file path=customXml/item2.xml><?xml version="1.0" encoding="utf-8"?>
+<p:properties xmlns:p="http://schemas.microsoft.com/office/2006/metadata/properties" xmlns:xsi="http://www.w3.org/2001/XMLSchema-instance" xmlns:pc="http://schemas.microsoft.com/office/infopath/2007/PartnerControls">
+  <documentManagement>
+    <lcf76f155ced4ddcb4097134ff3c332f xmlns="c0caafef-fd22-48d0-85dc-526f5aa604f6">
+      <Terms xmlns="http://schemas.microsoft.com/office/infopath/2007/PartnerControls"/>
+    </lcf76f155ced4ddcb4097134ff3c332f>
+    <TaxCatchAll xmlns="cc7ce8ca-8f52-44ec-9496-3c41d0f5ad18" xsi:nil="true"/>
+  </documentManagement>
+</p:properties>
+</file>
+
+<file path=customXml/item3.xml><?xml version="1.0" encoding="utf-8"?>
 <ct:contentTypeSchema xmlns:ct="http://schemas.microsoft.com/office/2006/metadata/contentType" xmlns:ma="http://schemas.microsoft.com/office/2006/metadata/properties/metaAttributes" ct:_="" ma:_="" ma:contentTypeName="Document" ma:contentTypeID="0x01010072500CC7CC11694381E56D15BD009ABF" ma:contentTypeVersion="17" ma:contentTypeDescription="Create a new document." ma:contentTypeScope="" ma:versionID="5bde0183fae20f930619151b743545d5">
   <xsd:schema xmlns:xsd="http://www.w3.org/2001/XMLSchema" xmlns:xs="http://www.w3.org/2001/XMLSchema" xmlns:p="http://schemas.microsoft.com/office/2006/metadata/properties" xmlns:ns2="c0caafef-fd22-48d0-85dc-526f5aa604f6" xmlns:ns3="cc7ce8ca-8f52-44ec-9496-3c41d0f5ad18" targetNamespace="http://schemas.microsoft.com/office/2006/metadata/properties" ma:root="true" ma:fieldsID="b93acc077f3eeba91a697f445d89f976" ns2:_="" ns3:_="">
     <xsd:import namespace="c0caafef-fd22-48d0-85dc-526f5aa604f6"/>
@@ -8063,27 +8195,26 @@
 </ct:contentTypeSchema>
 </file>
 
-<file path=customXml/item2.xml><?xml version="1.0" encoding="utf-8"?>
-<p:properties xmlns:p="http://schemas.microsoft.com/office/2006/metadata/properties" xmlns:xsi="http://www.w3.org/2001/XMLSchema-instance" xmlns:pc="http://schemas.microsoft.com/office/infopath/2007/PartnerControls">
-  <documentManagement>
-    <lcf76f155ced4ddcb4097134ff3c332f xmlns="c0caafef-fd22-48d0-85dc-526f5aa604f6">
-      <Terms xmlns="http://schemas.microsoft.com/office/infopath/2007/PartnerControls"/>
-    </lcf76f155ced4ddcb4097134ff3c332f>
-    <TaxCatchAll xmlns="cc7ce8ca-8f52-44ec-9496-3c41d0f5ad18" xsi:nil="true"/>
-  </documentManagement>
-</p:properties>
+<file path=customXml/itemProps1.xml><?xml version="1.0" encoding="utf-8"?>
+<ds:datastoreItem xmlns:ds="http://schemas.openxmlformats.org/officeDocument/2006/customXml" ds:itemID="{3A3DF9AB-00FC-46DB-A5D6-293E8DE99346}">
+  <ds:schemaRefs>
+    <ds:schemaRef ds:uri="http://schemas.microsoft.com/sharepoint/v3/contenttype/forms"/>
+  </ds:schemaRefs>
+</ds:datastoreItem>
 </file>
 
-<file path=customXml/item3.xml><?xml version="1.0" encoding="utf-8"?>
-<?mso-contentType ?>
-<FormTemplates xmlns="http://schemas.microsoft.com/sharepoint/v3/contenttype/forms">
-  <Display>DocumentLibraryForm</Display>
-  <Edit>DocumentLibraryForm</Edit>
-  <New>DocumentLibraryForm</New>
-</FormTemplates>
+<file path=customXml/itemProps2.xml><?xml version="1.0" encoding="utf-8"?>
+<ds:datastoreItem xmlns:ds="http://schemas.openxmlformats.org/officeDocument/2006/customXml" ds:itemID="{E17CF73B-06D3-4F9B-955D-0740B08863BD}">
+  <ds:schemaRefs>
+    <ds:schemaRef ds:uri="http://schemas.microsoft.com/office/2006/metadata/properties"/>
+    <ds:schemaRef ds:uri="http://schemas.microsoft.com/office/infopath/2007/PartnerControls"/>
+    <ds:schemaRef ds:uri="c0caafef-fd22-48d0-85dc-526f5aa604f6"/>
+    <ds:schemaRef ds:uri="cc7ce8ca-8f52-44ec-9496-3c41d0f5ad18"/>
+  </ds:schemaRefs>
+</ds:datastoreItem>
 </file>
 
-<file path=customXml/itemProps1.xml><?xml version="1.0" encoding="utf-8"?>
+<file path=customXml/itemProps3.xml><?xml version="1.0" encoding="utf-8"?>
 <ds:datastoreItem xmlns:ds="http://schemas.openxmlformats.org/officeDocument/2006/customXml" ds:itemID="{F8E82391-0565-41E9-9127-B1DFEFCF6557}">
   <ds:schemaRefs>
     <ds:schemaRef ds:uri="http://schemas.microsoft.com/office/2006/metadata/contentType"/>
@@ -8100,23 +8231,4 @@
     <ds:schemaRef ds:uri="http://schemas.microsoft.com/internal/obd"/>
   </ds:schemaRefs>
 </ds:datastoreItem>
-</file>
-
-<file path=customXml/itemProps2.xml><?xml version="1.0" encoding="utf-8"?>
-<ds:datastoreItem xmlns:ds="http://schemas.openxmlformats.org/officeDocument/2006/customXml" ds:itemID="{E17CF73B-06D3-4F9B-955D-0740B08863BD}">
-  <ds:schemaRefs>
-    <ds:schemaRef ds:uri="http://schemas.microsoft.com/office/2006/metadata/properties"/>
-    <ds:schemaRef ds:uri="http://schemas.microsoft.com/office/infopath/2007/PartnerControls"/>
-    <ds:schemaRef ds:uri="c0caafef-fd22-48d0-85dc-526f5aa604f6"/>
-    <ds:schemaRef ds:uri="cc7ce8ca-8f52-44ec-9496-3c41d0f5ad18"/>
-  </ds:schemaRefs>
-</ds:datastoreItem>
-</file>
-
-<file path=customXml/itemProps3.xml><?xml version="1.0" encoding="utf-8"?>
-<ds:datastoreItem xmlns:ds="http://schemas.openxmlformats.org/officeDocument/2006/customXml" ds:itemID="{3A3DF9AB-00FC-46DB-A5D6-293E8DE99346}">
-  <ds:schemaRefs>
-    <ds:schemaRef ds:uri="http://schemas.microsoft.com/sharepoint/v3/contenttype/forms"/>
-  </ds:schemaRefs>
-</ds:datastoreItem>
 </file>
</xml_diff>